<commit_message>
updated ppt for ch0
</commit_message>
<xml_diff>
--- a/Ch0_Tools_You_Need.pptx
+++ b/Ch0_Tools_You_Need.pptx
@@ -3681,7 +3681,7 @@
         <p:spPr>
           <a:xfrm>
             <a:off x="640080" y="3657600"/>
-            <a:ext cx="10972800" cy="4480560"/>
+            <a:ext cx="10972800" cy="713016"/>
           </a:xfrm>
           <a:prstGeom prst="rect">
             <a:avLst/>
@@ -3703,7 +3703,7 @@
               </a:spcAft>
             </a:pPr>
             <a:r>
-              <a:rPr sz="1900" b="1" i="0">
+              <a:rPr sz="1900" b="1" i="0" dirty="0">
                 <a:solidFill>
                   <a:srgbClr val="0EA5E9"/>
                 </a:solidFill>
@@ -3712,7 +3712,7 @@
               <a:t>▪  </a:t>
             </a:r>
             <a:r>
-              <a:rPr sz="1900" b="0" i="0">
+              <a:rPr sz="1900" b="0" i="0" dirty="0">
                 <a:solidFill>
                   <a:srgbClr val="334155"/>
                 </a:solidFill>
@@ -3731,7 +3731,7 @@
               </a:spcAft>
             </a:pPr>
             <a:r>
-              <a:rPr sz="1900" b="1" i="0">
+              <a:rPr sz="1900" b="1" i="0" dirty="0">
                 <a:solidFill>
                   <a:srgbClr val="0EA5E9"/>
                 </a:solidFill>
@@ -3740,41 +3740,112 @@
               <a:t>▪  </a:t>
             </a:r>
             <a:r>
-              <a:rPr sz="1900" b="0" i="0">
+              <a:rPr sz="1900" b="0" i="0" dirty="0">
                 <a:solidFill>
                   <a:srgbClr val="334155"/>
                 </a:solidFill>
                 <a:latin typeface="Segoe UI"/>
               </a:rPr>
-              <a:t>Core: ultralytics, opencv-python, numpy, mediapipe,</a:t>
-            </a:r>
-          </a:p>
-          <a:p>
-            <a:pPr lvl="1">
-              <a:spcBef>
-                <a:spcPts val="0"/>
-              </a:spcBef>
-              <a:spcAft>
-                <a:spcPts val="1000"/>
-              </a:spcAft>
-            </a:pPr>
-            <a:r>
-              <a:rPr sz="1700" b="0" i="0">
-                <a:solidFill>
-                  <a:srgbClr val="94A3B8"/>
-                </a:solidFill>
-                <a:latin typeface="Segoe UI"/>
-              </a:rPr>
-              <a:t>      –  </a:t>
-            </a:r>
-            <a:r>
-              <a:rPr sz="1700" b="0" i="0">
+              <a:t>Core: </a:t>
+            </a:r>
+            <a:r>
+              <a:rPr sz="1900" b="0" i="0" dirty="0" err="1">
                 <a:solidFill>
                   <a:srgbClr val="334155"/>
                 </a:solidFill>
                 <a:latin typeface="Segoe UI"/>
               </a:rPr>
-              <a:t>tensorflow, teachable-machine, requests, urllib3</a:t>
+              <a:t>ultralytics</a:t>
+            </a:r>
+            <a:r>
+              <a:rPr sz="1900" b="0" i="0" dirty="0">
+                <a:solidFill>
+                  <a:srgbClr val="334155"/>
+                </a:solidFill>
+                <a:latin typeface="Segoe UI"/>
+              </a:rPr>
+              <a:t>, </a:t>
+            </a:r>
+            <a:r>
+              <a:rPr sz="1900" b="0" i="0" dirty="0" err="1">
+                <a:solidFill>
+                  <a:srgbClr val="334155"/>
+                </a:solidFill>
+                <a:latin typeface="Segoe UI"/>
+              </a:rPr>
+              <a:t>opencv</a:t>
+            </a:r>
+            <a:r>
+              <a:rPr sz="1900" b="0" i="0" dirty="0">
+                <a:solidFill>
+                  <a:srgbClr val="334155"/>
+                </a:solidFill>
+                <a:latin typeface="Segoe UI"/>
+              </a:rPr>
+              <a:t>-python, </a:t>
+            </a:r>
+            <a:r>
+              <a:rPr sz="1900" b="0" i="0" dirty="0" err="1">
+                <a:solidFill>
+                  <a:srgbClr val="334155"/>
+                </a:solidFill>
+                <a:latin typeface="Segoe UI"/>
+              </a:rPr>
+              <a:t>numpy</a:t>
+            </a:r>
+            <a:r>
+              <a:rPr sz="1900" b="0" i="0" dirty="0">
+                <a:solidFill>
+                  <a:srgbClr val="334155"/>
+                </a:solidFill>
+                <a:latin typeface="Segoe UI"/>
+              </a:rPr>
+              <a:t>, </a:t>
+            </a:r>
+            <a:r>
+              <a:rPr sz="1900" b="0" i="0" dirty="0" err="1">
+                <a:solidFill>
+                  <a:srgbClr val="334155"/>
+                </a:solidFill>
+                <a:latin typeface="Segoe UI"/>
+              </a:rPr>
+              <a:t>mediapipe</a:t>
+            </a:r>
+            <a:r>
+              <a:rPr sz="1900" b="0" i="0" dirty="0">
+                <a:solidFill>
+                  <a:srgbClr val="334155"/>
+                </a:solidFill>
+                <a:latin typeface="Segoe UI"/>
+              </a:rPr>
+              <a:t>,</a:t>
+            </a:r>
+            <a:r>
+              <a:rPr lang="en-US" sz="1900" b="0" i="0" dirty="0">
+                <a:solidFill>
+                  <a:srgbClr val="334155"/>
+                </a:solidFill>
+                <a:latin typeface="Segoe UI"/>
+              </a:rPr>
+              <a:t> </a:t>
+            </a:r>
+            <a:r>
+              <a:rPr sz="1900" dirty="0" err="1">
+                <a:solidFill>
+                  <a:srgbClr val="334155"/>
+                </a:solidFill>
+                <a:latin typeface="Segoe UI"/>
+              </a:rPr>
+              <a:t>tensorflow</a:t>
+            </a:r>
+            <a:r>
+              <a:rPr sz="1900" dirty="0">
+                <a:solidFill>
+                  <a:srgbClr val="334155"/>
+                </a:solidFill>
+                <a:latin typeface="Segoe UI"/>
+              </a:rPr>
+              <a:t>, teachable-machine, requests, urllib3</a:t>
             </a:r>
           </a:p>
         </p:txBody>
@@ -4811,7 +4882,7 @@
         <p:spPr>
           <a:xfrm>
             <a:off x="640080" y="1554480"/>
-            <a:ext cx="10972800" cy="1280160"/>
+            <a:ext cx="10972800" cy="2303195"/>
           </a:xfrm>
           <a:prstGeom prst="rect">
             <a:avLst/>
@@ -4833,7 +4904,7 @@
               </a:spcAft>
             </a:pPr>
             <a:r>
-              <a:rPr sz="1900" b="1" i="0">
+              <a:rPr sz="1900" b="1" i="0" dirty="0">
                 <a:solidFill>
                   <a:srgbClr val="0EA5E9"/>
                 </a:solidFill>
@@ -4842,7 +4913,7 @@
               <a:t>▪  </a:t>
             </a:r>
             <a:r>
-              <a:rPr sz="1900" b="0" i="0">
+              <a:rPr sz="1900" b="0" i="0" dirty="0">
                 <a:solidFill>
                   <a:srgbClr val="334155"/>
                 </a:solidFill>
@@ -4861,7 +4932,7 @@
               </a:spcAft>
             </a:pPr>
             <a:r>
-              <a:rPr sz="1900" b="1" i="0">
+              <a:rPr sz="1900" b="1" i="0" dirty="0">
                 <a:solidFill>
                   <a:srgbClr val="0EA5E9"/>
                 </a:solidFill>
@@ -4870,14 +4941,110 @@
               <a:t>▪  </a:t>
             </a:r>
             <a:r>
-              <a:rPr sz="1900" b="0" i="0">
+              <a:rPr sz="1900" b="0" i="0" dirty="0">
                 <a:solidFill>
                   <a:srgbClr val="334155"/>
                 </a:solidFill>
                 <a:latin typeface="Segoe UI"/>
               </a:rPr>
-              <a:t>Turn off auto-update in VS Code settings:</a:t>
-            </a:r>
+              <a:t>Turn off auto-update in VS Code settings</a:t>
+            </a:r>
+            <a:r>
+              <a:rPr lang="en-US" sz="1900" dirty="0">
+                <a:solidFill>
+                  <a:srgbClr val="334155"/>
+                </a:solidFill>
+                <a:latin typeface="Segoe UI"/>
+              </a:rPr>
+              <a:t> by editing </a:t>
+            </a:r>
+            <a:r>
+              <a:rPr lang="en-US" sz="1900" dirty="0" err="1">
+                <a:solidFill>
+                  <a:srgbClr val="334155"/>
+                </a:solidFill>
+                <a:latin typeface="Segoe UI"/>
+              </a:rPr>
+              <a:t>settings.json</a:t>
+            </a:r>
+            <a:r>
+              <a:rPr lang="en-US" sz="1900" dirty="0">
+                <a:solidFill>
+                  <a:srgbClr val="334155"/>
+                </a:solidFill>
+                <a:latin typeface="Segoe UI"/>
+              </a:rPr>
+              <a:t> file:</a:t>
+            </a:r>
+          </a:p>
+          <a:p>
+            <a:pPr marL="457200" indent="-457200">
+              <a:buFont typeface="+mj-lt"/>
+              <a:buAutoNum type="arabicPeriod"/>
+            </a:pPr>
+            <a:r>
+              <a:rPr lang="en-US" sz="1900" dirty="0">
+                <a:solidFill>
+                  <a:srgbClr val="334155"/>
+                </a:solidFill>
+                <a:latin typeface="Segoe UI"/>
+              </a:rPr>
+              <a:t>Open the VS Code Command Palette by pressing Ctrl + Shift + P (Windows/Linux) or </a:t>
+            </a:r>
+            <a:r>
+              <a:rPr lang="en-US" sz="1900" dirty="0" err="1">
+                <a:solidFill>
+                  <a:srgbClr val="334155"/>
+                </a:solidFill>
+                <a:latin typeface="Segoe UI"/>
+              </a:rPr>
+              <a:t>Cmd</a:t>
+            </a:r>
+            <a:r>
+              <a:rPr lang="en-US" sz="1900" dirty="0">
+                <a:solidFill>
+                  <a:srgbClr val="334155"/>
+                </a:solidFill>
+                <a:latin typeface="Segoe UI"/>
+              </a:rPr>
+              <a:t> + Shift + P (macOS).</a:t>
+            </a:r>
+          </a:p>
+          <a:p>
+            <a:pPr marL="457200" indent="-457200">
+              <a:buFont typeface="+mj-lt"/>
+              <a:buAutoNum type="arabicPeriod"/>
+            </a:pPr>
+            <a:r>
+              <a:rPr lang="en-US" sz="1900" dirty="0">
+                <a:solidFill>
+                  <a:srgbClr val="334155"/>
+                </a:solidFill>
+                <a:latin typeface="Segoe UI"/>
+              </a:rPr>
+              <a:t>Type "Preferences: Open User Settings (JSON)" and select it from the list.</a:t>
+            </a:r>
+          </a:p>
+          <a:p>
+            <a:pPr marL="457200" indent="-457200">
+              <a:buFont typeface="+mj-lt"/>
+              <a:buAutoNum type="arabicPeriod"/>
+            </a:pPr>
+            <a:r>
+              <a:rPr lang="en-US" sz="1900" dirty="0">
+                <a:solidFill>
+                  <a:srgbClr val="334155"/>
+                </a:solidFill>
+                <a:latin typeface="Segoe UI"/>
+              </a:rPr>
+              <a:t>Paste the following three configuration lines inside the curly brackets {}. Be sure to add a comma at the end of your existing settings if you place them in the middle of the file. </a:t>
+            </a:r>
+            <a:endParaRPr sz="1900" b="0" i="0" dirty="0">
+              <a:solidFill>
+                <a:srgbClr val="334155"/>
+              </a:solidFill>
+              <a:latin typeface="Segoe UI"/>
+            </a:endParaRPr>
           </a:p>
         </p:txBody>
       </p:sp>
@@ -4889,7 +5056,7 @@
         </p:nvSpPr>
         <p:spPr>
           <a:xfrm>
-            <a:off x="822960" y="2834640"/>
+            <a:off x="640080" y="4106424"/>
             <a:ext cx="10515600" cy="1207008"/>
           </a:xfrm>
           <a:prstGeom prst="rect">
@@ -5017,8 +5184,8 @@
         </p:nvSpPr>
         <p:spPr>
           <a:xfrm>
-            <a:off x="640080" y="4297680"/>
-            <a:ext cx="10972800" cy="4480560"/>
+            <a:off x="566928" y="5500381"/>
+            <a:ext cx="10074303" cy="713016"/>
           </a:xfrm>
           <a:prstGeom prst="rect">
             <a:avLst/>
@@ -5040,7 +5207,7 @@
               </a:spcAft>
             </a:pPr>
             <a:r>
-              <a:rPr sz="1900" b="1" i="0">
+              <a:rPr sz="1900" b="1" i="0" dirty="0">
                 <a:solidFill>
                   <a:srgbClr val="0EA5E9"/>
                 </a:solidFill>
@@ -5049,7 +5216,7 @@
               <a:t>▪  </a:t>
             </a:r>
             <a:r>
-              <a:rPr sz="1900" b="0" i="0">
+              <a:rPr sz="1900" b="0" i="0" dirty="0">
                 <a:solidFill>
                   <a:srgbClr val="334155"/>
                 </a:solidFill>
@@ -5068,7 +5235,7 @@
               </a:spcAft>
             </a:pPr>
             <a:r>
-              <a:rPr sz="1900" b="1" i="0">
+              <a:rPr sz="1900" b="1" i="0" dirty="0">
                 <a:solidFill>
                   <a:srgbClr val="0EA5E9"/>
                 </a:solidFill>
@@ -5077,7 +5244,7 @@
               <a:t>▪  </a:t>
             </a:r>
             <a:r>
-              <a:rPr sz="1900" b="0" i="0">
+              <a:rPr sz="1900" b="0" i="0" dirty="0">
                 <a:solidFill>
                   <a:srgbClr val="334155"/>
                 </a:solidFill>
@@ -6238,7 +6405,7 @@
         <p:spPr>
           <a:xfrm>
             <a:off x="640080" y="1600200"/>
-            <a:ext cx="10972800" cy="4480560"/>
+            <a:ext cx="10972800" cy="3236784"/>
           </a:xfrm>
           <a:prstGeom prst="rect">
             <a:avLst/>
@@ -6260,14 +6427,29 @@
               </a:spcAft>
             </a:pPr>
             <a:r>
-              <a:rPr sz="2100" b="1" i="0">
+              <a:rPr sz="2100" b="1" i="0" dirty="0">
                 <a:solidFill>
                   <a:srgbClr val="0EA5E9"/>
                 </a:solidFill>
                 <a:latin typeface="Segoe UI"/>
               </a:rPr>
-              <a:t>Early chapters — in the browser &amp; Google Colab</a:t>
-            </a:r>
+              <a:t>Early chapters — in the browser &amp; Google </a:t>
+            </a:r>
+            <a:r>
+              <a:rPr sz="2100" b="1" i="0" dirty="0" err="1">
+                <a:solidFill>
+                  <a:srgbClr val="0EA5E9"/>
+                </a:solidFill>
+                <a:latin typeface="Segoe UI"/>
+              </a:rPr>
+              <a:t>Colab</a:t>
+            </a:r>
+            <a:endParaRPr sz="2100" b="1" i="0" dirty="0">
+              <a:solidFill>
+                <a:srgbClr val="0EA5E9"/>
+              </a:solidFill>
+              <a:latin typeface="Segoe UI"/>
+            </a:endParaRPr>
           </a:p>
           <a:p>
             <a:pPr>
@@ -6279,7 +6461,7 @@
               </a:spcAft>
             </a:pPr>
             <a:r>
-              <a:rPr sz="1900" b="1" i="0">
+              <a:rPr sz="1900" b="1" i="0" dirty="0">
                 <a:solidFill>
                   <a:srgbClr val="0EA5E9"/>
                 </a:solidFill>
@@ -6288,7 +6470,7 @@
               <a:t>▪  </a:t>
             </a:r>
             <a:r>
-              <a:rPr sz="1900" b="0" i="0">
+              <a:rPr sz="1900" b="0" i="0" dirty="0">
                 <a:solidFill>
                   <a:srgbClr val="334155"/>
                 </a:solidFill>
@@ -6307,7 +6489,7 @@
               </a:spcAft>
             </a:pPr>
             <a:r>
-              <a:rPr sz="1900" b="1" i="0">
+              <a:rPr sz="1900" b="1" i="0" dirty="0">
                 <a:solidFill>
                   <a:srgbClr val="0EA5E9"/>
                 </a:solidFill>
@@ -6316,14 +6498,29 @@
               <a:t>▪  </a:t>
             </a:r>
             <a:r>
-              <a:rPr sz="1900" b="0" i="0">
+              <a:rPr sz="1900" b="0" i="0" dirty="0">
                 <a:solidFill>
                   <a:srgbClr val="334155"/>
                 </a:solidFill>
                 <a:latin typeface="Segoe UI"/>
               </a:rPr>
-              <a:t>ML and computer-vision notebooks run in Google Colab</a:t>
-            </a:r>
+              <a:t>ML notebooks run in Google </a:t>
+            </a:r>
+            <a:r>
+              <a:rPr sz="1900" b="0" i="0" dirty="0" err="1">
+                <a:solidFill>
+                  <a:srgbClr val="334155"/>
+                </a:solidFill>
+                <a:latin typeface="Segoe UI"/>
+              </a:rPr>
+              <a:t>Colab</a:t>
+            </a:r>
+            <a:endParaRPr sz="1900" b="0" i="0" dirty="0">
+              <a:solidFill>
+                <a:srgbClr val="334155"/>
+              </a:solidFill>
+              <a:latin typeface="Segoe UI"/>
+            </a:endParaRPr>
           </a:p>
           <a:p>
             <a:pPr lvl="1">
@@ -6335,7 +6532,7 @@
               </a:spcAft>
             </a:pPr>
             <a:r>
-              <a:rPr sz="1700" b="0" i="0">
+              <a:rPr sz="1700" b="0" i="0" dirty="0">
                 <a:solidFill>
                   <a:srgbClr val="94A3B8"/>
                 </a:solidFill>
@@ -6344,7 +6541,7 @@
               <a:t>      –  </a:t>
             </a:r>
             <a:r>
-              <a:rPr sz="1700" b="0" i="0">
+              <a:rPr sz="1700" b="0" i="0" dirty="0">
                 <a:solidFill>
                   <a:srgbClr val="334155"/>
                 </a:solidFill>
@@ -6363,7 +6560,7 @@
               </a:spcAft>
             </a:pPr>
             <a:r>
-              <a:rPr sz="2100" b="1" i="0">
+              <a:rPr sz="2100" b="1" i="0" dirty="0">
                 <a:solidFill>
                   <a:srgbClr val="0EA5E9"/>
                 </a:solidFill>
@@ -6382,7 +6579,7 @@
               </a:spcAft>
             </a:pPr>
             <a:r>
-              <a:rPr sz="1900" b="1" i="0">
+              <a:rPr sz="1900" b="1" i="0" dirty="0">
                 <a:solidFill>
                   <a:srgbClr val="0EA5E9"/>
                 </a:solidFill>
@@ -6391,14 +6588,29 @@
               <a:t>▪  </a:t>
             </a:r>
             <a:r>
-              <a:rPr sz="1900" b="0" i="0">
+              <a:rPr sz="1900" b="0" i="0" dirty="0">
                 <a:solidFill>
                   <a:srgbClr val="334155"/>
                 </a:solidFill>
                 <a:latin typeface="Segoe UI"/>
               </a:rPr>
-              <a:t>You deploy code to a real robot over WiFi</a:t>
-            </a:r>
+              <a:t>You deploy code to a real robot over </a:t>
+            </a:r>
+            <a:r>
+              <a:rPr sz="1900" b="0" i="0" dirty="0" err="1">
+                <a:solidFill>
+                  <a:srgbClr val="334155"/>
+                </a:solidFill>
+                <a:latin typeface="Segoe UI"/>
+              </a:rPr>
+              <a:t>WiFi</a:t>
+            </a:r>
+            <a:endParaRPr sz="1900" b="0" i="0" dirty="0">
+              <a:solidFill>
+                <a:srgbClr val="334155"/>
+              </a:solidFill>
+              <a:latin typeface="Segoe UI"/>
+            </a:endParaRPr>
           </a:p>
           <a:p>
             <a:pPr>
@@ -6410,7 +6622,7 @@
               </a:spcAft>
             </a:pPr>
             <a:r>
-              <a:rPr sz="1900" b="1" i="0">
+              <a:rPr sz="1900" b="1" i="0" dirty="0">
                 <a:solidFill>
                   <a:srgbClr val="0EA5E9"/>
                 </a:solidFill>
@@ -6419,7 +6631,7 @@
               <a:t>▪  </a:t>
             </a:r>
             <a:r>
-              <a:rPr sz="1900" b="0" i="0">
+              <a:rPr sz="1900" b="0" i="0" dirty="0">
                 <a:solidFill>
                   <a:srgbClr val="334155"/>
                 </a:solidFill>
@@ -6438,7 +6650,7 @@
               </a:spcAft>
             </a:pPr>
             <a:r>
-              <a:rPr sz="1700" b="0" i="0">
+              <a:rPr sz="1700" b="0" i="0" dirty="0">
                 <a:solidFill>
                   <a:srgbClr val="94A3B8"/>
                 </a:solidFill>
@@ -6447,7 +6659,7 @@
               <a:t>      –  </a:t>
             </a:r>
             <a:r>
-              <a:rPr sz="1700" b="0" i="0">
+              <a:rPr sz="1700" b="0" i="0" dirty="0">
                 <a:solidFill>
                   <a:srgbClr val="334155"/>
                 </a:solidFill>
@@ -6730,7 +6942,7 @@
         <p:spPr>
           <a:xfrm>
             <a:off x="640080" y="1600200"/>
-            <a:ext cx="10972800" cy="4480560"/>
+            <a:ext cx="10972800" cy="2333972"/>
           </a:xfrm>
           <a:prstGeom prst="rect">
             <a:avLst/>
@@ -6752,7 +6964,7 @@
               </a:spcAft>
             </a:pPr>
             <a:r>
-              <a:rPr sz="1900" b="1" i="0">
+              <a:rPr sz="1900" b="1" i="0" dirty="0">
                 <a:solidFill>
                   <a:srgbClr val="0EA5E9"/>
                 </a:solidFill>
@@ -6761,7 +6973,7 @@
               <a:t>▪  </a:t>
             </a:r>
             <a:r>
-              <a:rPr sz="1900" b="0" i="0">
+              <a:rPr sz="1900" b="0" i="0" dirty="0">
                 <a:solidFill>
                   <a:srgbClr val="334155"/>
                 </a:solidFill>
@@ -6780,7 +6992,7 @@
               </a:spcAft>
             </a:pPr>
             <a:r>
-              <a:rPr sz="1700" b="0" i="0">
+              <a:rPr sz="1700" b="0" i="0" dirty="0">
                 <a:solidFill>
                   <a:srgbClr val="94A3B8"/>
                 </a:solidFill>
@@ -6789,13 +7001,67 @@
               <a:t>      –  </a:t>
             </a:r>
             <a:r>
-              <a:rPr sz="1700" b="0" i="0">
+              <a:rPr sz="1700" b="0" i="0" dirty="0">
                 <a:solidFill>
                   <a:srgbClr val="334155"/>
                 </a:solidFill>
                 <a:latin typeface="Segoe UI"/>
               </a:rPr>
-              <a:t>Powered by CPython 3.12 compiled to WebAssembly (Pyodide)</a:t>
+              <a:t>Powered by </a:t>
+            </a:r>
+            <a:r>
+              <a:rPr sz="1700" b="0" i="0" dirty="0" err="1">
+                <a:solidFill>
+                  <a:srgbClr val="334155"/>
+                </a:solidFill>
+                <a:latin typeface="Segoe UI"/>
+              </a:rPr>
+              <a:t>CPython</a:t>
+            </a:r>
+            <a:r>
+              <a:rPr sz="1700" b="0" i="0" dirty="0">
+                <a:solidFill>
+                  <a:srgbClr val="334155"/>
+                </a:solidFill>
+                <a:latin typeface="Segoe UI"/>
+              </a:rPr>
+              <a:t> 3.12 compiled to </a:t>
+            </a:r>
+            <a:r>
+              <a:rPr sz="1700" b="0" i="0" dirty="0" err="1">
+                <a:solidFill>
+                  <a:srgbClr val="334155"/>
+                </a:solidFill>
+                <a:latin typeface="Segoe UI"/>
+              </a:rPr>
+              <a:t>WebAssembly</a:t>
+            </a:r>
+            <a:r>
+              <a:rPr sz="1700" b="0" i="0" dirty="0">
+                <a:solidFill>
+                  <a:srgbClr val="334155"/>
+                </a:solidFill>
+                <a:latin typeface="Segoe UI"/>
+              </a:rPr>
+              <a:t> (</a:t>
+            </a:r>
+            <a:r>
+              <a:rPr sz="1700" b="0" i="0" dirty="0" err="1">
+                <a:solidFill>
+                  <a:srgbClr val="334155"/>
+                </a:solidFill>
+                <a:latin typeface="Segoe UI"/>
+              </a:rPr>
+              <a:t>Pyodide</a:t>
+            </a:r>
+            <a:r>
+              <a:rPr sz="1700" b="0" i="0" dirty="0">
+                <a:solidFill>
+                  <a:srgbClr val="334155"/>
+                </a:solidFill>
+                <a:latin typeface="Segoe UI"/>
+              </a:rPr>
+              <a:t>)</a:t>
             </a:r>
           </a:p>
           <a:p>
@@ -6808,7 +7074,7 @@
               </a:spcAft>
             </a:pPr>
             <a:r>
-              <a:rPr sz="1900" b="1" i="0">
+              <a:rPr sz="1900" b="1" i="0" dirty="0">
                 <a:solidFill>
                   <a:srgbClr val="0EA5E9"/>
                 </a:solidFill>
@@ -6817,13 +7083,31 @@
               <a:t>▪  </a:t>
             </a:r>
             <a:r>
-              <a:rPr sz="1900" b="0" i="0">
+              <a:rPr sz="1900" b="0" i="0" dirty="0">
                 <a:solidFill>
                   <a:srgbClr val="334155"/>
                 </a:solidFill>
                 <a:latin typeface="Segoe UI"/>
               </a:rPr>
-              <a:t>Use Google Colab for the ML &amp; vision notebooks</a:t>
+              <a:t>Use Google </a:t>
+            </a:r>
+            <a:r>
+              <a:rPr sz="1900" b="0" i="0" dirty="0" err="1">
+                <a:solidFill>
+                  <a:srgbClr val="334155"/>
+                </a:solidFill>
+                <a:latin typeface="Segoe UI"/>
+              </a:rPr>
+              <a:t>Colab</a:t>
+            </a:r>
+            <a:r>
+              <a:rPr sz="1900" b="0" i="0" dirty="0">
+                <a:solidFill>
+                  <a:srgbClr val="334155"/>
+                </a:solidFill>
+                <a:latin typeface="Segoe UI"/>
+              </a:rPr>
+              <a:t> for the ML notebooks</a:t>
             </a:r>
           </a:p>
           <a:p>
@@ -6836,7 +7120,7 @@
               </a:spcAft>
             </a:pPr>
             <a:r>
-              <a:rPr sz="1700" b="0" i="0">
+              <a:rPr sz="1700" b="0" i="0" dirty="0">
                 <a:solidFill>
                   <a:srgbClr val="94A3B8"/>
                 </a:solidFill>
@@ -6845,7 +7129,7 @@
               <a:t>      –  </a:t>
             </a:r>
             <a:r>
-              <a:rPr sz="1700" b="0" i="0">
+              <a:rPr sz="1700" b="0" i="0" dirty="0">
                 <a:solidFill>
                   <a:srgbClr val="334155"/>
                 </a:solidFill>
@@ -6864,7 +7148,7 @@
               </a:spcAft>
             </a:pPr>
             <a:r>
-              <a:rPr sz="1900" b="1" i="0">
+              <a:rPr sz="1900" b="1" i="0" dirty="0">
                 <a:solidFill>
                   <a:srgbClr val="0EA5E9"/>
                 </a:solidFill>
@@ -6873,7 +7157,7 @@
               <a:t>▪  </a:t>
             </a:r>
             <a:r>
-              <a:rPr sz="1900" b="0" i="0">
+              <a:rPr sz="1900" b="0" i="0" dirty="0">
                 <a:solidFill>
                   <a:srgbClr val="334155"/>
                 </a:solidFill>
@@ -6892,7 +7176,7 @@
               </a:spcAft>
             </a:pPr>
             <a:r>
-              <a:rPr sz="1900" b="1" i="0">
+              <a:rPr sz="1900" b="1" i="0" dirty="0">
                 <a:solidFill>
                   <a:srgbClr val="0EA5E9"/>
                 </a:solidFill>
@@ -6901,7 +7185,7 @@
               <a:t>▪  </a:t>
             </a:r>
             <a:r>
-              <a:rPr sz="1900" b="0" i="0">
+              <a:rPr sz="1900" b="0" i="0" dirty="0">
                 <a:solidFill>
                   <a:srgbClr val="334155"/>
                 </a:solidFill>
@@ -7184,7 +7468,7 @@
         <p:spPr>
           <a:xfrm>
             <a:off x="640080" y="1737360"/>
-            <a:ext cx="10972800" cy="4480560"/>
+            <a:ext cx="10972800" cy="2929007"/>
           </a:xfrm>
           <a:prstGeom prst="rect">
             <a:avLst/>
@@ -7206,7 +7490,7 @@
               </a:spcAft>
             </a:pPr>
             <a:r>
-              <a:rPr sz="2200" b="1" i="0">
+              <a:rPr sz="2200" b="1" i="0" dirty="0">
                 <a:solidFill>
                   <a:srgbClr val="0EA5E9"/>
                 </a:solidFill>
@@ -7215,7 +7499,7 @@
               <a:t>▪  </a:t>
             </a:r>
             <a:r>
-              <a:rPr sz="2200" b="0" i="0">
+              <a:rPr sz="2200" b="0" i="0" dirty="0">
                 <a:solidFill>
                   <a:srgbClr val="334155"/>
                 </a:solidFill>
@@ -7234,7 +7518,7 @@
               </a:spcAft>
             </a:pPr>
             <a:r>
-              <a:rPr sz="2200" b="1" i="0">
+              <a:rPr sz="2200" b="1" i="0" dirty="0">
                 <a:solidFill>
                   <a:srgbClr val="0EA5E9"/>
                 </a:solidFill>
@@ -7243,7 +7527,7 @@
               <a:t>▪  </a:t>
             </a:r>
             <a:r>
-              <a:rPr sz="2200" b="0" i="0">
+              <a:rPr sz="2200" b="0" i="0" dirty="0">
                 <a:solidFill>
                   <a:srgbClr val="334155"/>
                 </a:solidFill>
@@ -7262,7 +7546,7 @@
               </a:spcAft>
             </a:pPr>
             <a:r>
-              <a:rPr sz="2200" b="1" i="0">
+              <a:rPr sz="2200" b="1" i="0" dirty="0">
                 <a:solidFill>
                   <a:srgbClr val="0EA5E9"/>
                 </a:solidFill>
@@ -7271,7 +7555,7 @@
               <a:t>▪  </a:t>
             </a:r>
             <a:r>
-              <a:rPr sz="2200" b="0" i="0">
+              <a:rPr sz="2200" b="0" i="0" dirty="0">
                 <a:solidFill>
                   <a:srgbClr val="334155"/>
                 </a:solidFill>
@@ -7290,7 +7574,7 @@
               </a:spcAft>
             </a:pPr>
             <a:r>
-              <a:rPr sz="2200" b="1" i="0">
+              <a:rPr sz="2200" b="1" i="0" dirty="0">
                 <a:solidFill>
                   <a:srgbClr val="0EA5E9"/>
                 </a:solidFill>
@@ -7299,7 +7583,7 @@
               <a:t>▪  </a:t>
             </a:r>
             <a:r>
-              <a:rPr sz="2200" b="0" i="0">
+              <a:rPr sz="2200" b="0" i="0" dirty="0">
                 <a:solidFill>
                   <a:srgbClr val="334155"/>
                 </a:solidFill>
@@ -7318,7 +7602,7 @@
               </a:spcAft>
             </a:pPr>
             <a:r>
-              <a:rPr sz="2200" b="1" i="0">
+              <a:rPr sz="2200" b="1" i="0" dirty="0">
                 <a:solidFill>
                   <a:srgbClr val="0EA5E9"/>
                 </a:solidFill>
@@ -7327,7 +7611,7 @@
               <a:t>▪  </a:t>
             </a:r>
             <a:r>
-              <a:rPr sz="2200" b="0" i="0">
+              <a:rPr sz="2200" b="0" i="0" dirty="0">
                 <a:solidFill>
                   <a:srgbClr val="334155"/>
                 </a:solidFill>
@@ -7346,7 +7630,7 @@
               </a:spcAft>
             </a:pPr>
             <a:r>
-              <a:rPr sz="2200" b="1" i="0">
+              <a:rPr sz="2200" b="1" i="0" dirty="0">
                 <a:solidFill>
                   <a:srgbClr val="0EA5E9"/>
                 </a:solidFill>
@@ -7355,13 +7639,31 @@
               <a:t>▪  </a:t>
             </a:r>
             <a:r>
-              <a:rPr sz="2200" b="0" i="0">
+              <a:rPr sz="2200" b="0" i="0" dirty="0">
                 <a:solidFill>
                   <a:srgbClr val="334155"/>
                 </a:solidFill>
                 <a:latin typeface="Segoe UI"/>
               </a:rPr>
-              <a:t>6.  Install the course libraries</a:t>
+              <a:t>6.  Install the </a:t>
+            </a:r>
+            <a:r>
+              <a:rPr lang="en-US" sz="2200" b="0" i="0" dirty="0">
+                <a:solidFill>
+                  <a:srgbClr val="334155"/>
+                </a:solidFill>
+                <a:latin typeface="Segoe UI"/>
+              </a:rPr>
+              <a:t>Python </a:t>
+            </a:r>
+            <a:r>
+              <a:rPr sz="2200" b="0" i="0" dirty="0">
+                <a:solidFill>
+                  <a:srgbClr val="334155"/>
+                </a:solidFill>
+                <a:latin typeface="Segoe UI"/>
+              </a:rPr>
+              <a:t>libraries</a:t>
             </a:r>
           </a:p>
         </p:txBody>
@@ -7797,7 +8099,7 @@
         </p:nvSpPr>
         <p:spPr>
           <a:xfrm>
-            <a:off x="0" y="0"/>
+            <a:off x="0" y="6626"/>
             <a:ext cx="12191695" cy="6858000"/>
           </a:xfrm>
           <a:prstGeom prst="rect">
@@ -8195,8 +8497,8 @@
         </p:nvSpPr>
         <p:spPr>
           <a:xfrm>
-            <a:off x="640080" y="4160520"/>
-            <a:ext cx="10972800" cy="4480560"/>
+            <a:off x="708990" y="4160520"/>
+            <a:ext cx="10903889" cy="292388"/>
           </a:xfrm>
           <a:prstGeom prst="rect">
             <a:avLst/>
@@ -8218,7 +8520,7 @@
               </a:spcAft>
             </a:pPr>
             <a:r>
-              <a:rPr sz="1900" b="1" i="0">
+              <a:rPr sz="1900" b="1" i="0" dirty="0">
                 <a:solidFill>
                   <a:srgbClr val="0EA5E9"/>
                 </a:solidFill>
@@ -8227,7 +8529,7 @@
               <a:t>▪  </a:t>
             </a:r>
             <a:r>
-              <a:rPr sz="1900" b="0" i="0">
+              <a:rPr sz="1900" b="0" i="0" dirty="0">
                 <a:solidFill>
                   <a:srgbClr val="334155"/>
                 </a:solidFill>
@@ -9068,7 +9370,7 @@
         <p:spPr>
           <a:xfrm>
             <a:off x="640080" y="3977639"/>
-            <a:ext cx="10972800" cy="4480560"/>
+            <a:ext cx="10972800" cy="682238"/>
           </a:xfrm>
           <a:prstGeom prst="rect">
             <a:avLst/>
@@ -9090,7 +9392,7 @@
               </a:spcAft>
             </a:pPr>
             <a:r>
-              <a:rPr sz="1900" b="1" i="0">
+              <a:rPr sz="1900" b="1" i="0" dirty="0">
                 <a:solidFill>
                   <a:srgbClr val="0EA5E9"/>
                 </a:solidFill>
@@ -9099,7 +9401,7 @@
               <a:t>▪  </a:t>
             </a:r>
             <a:r>
-              <a:rPr sz="1900" b="0" i="0">
+              <a:rPr sz="1900" b="0" i="0" dirty="0">
                 <a:solidFill>
                   <a:srgbClr val="334155"/>
                 </a:solidFill>
@@ -9118,7 +9420,7 @@
               </a:spcAft>
             </a:pPr>
             <a:r>
-              <a:rPr sz="1700" b="0" i="0">
+              <a:rPr sz="1700" b="0" i="0" dirty="0">
                 <a:solidFill>
                   <a:srgbClr val="94A3B8"/>
                 </a:solidFill>
@@ -9127,41 +9429,13 @@
               <a:t>      –  </a:t>
             </a:r>
             <a:r>
-              <a:rPr sz="1700" b="0" i="0">
+              <a:rPr sz="1700" b="0" i="0" dirty="0">
                 <a:solidFill>
                   <a:srgbClr val="334155"/>
                 </a:solidFill>
                 <a:latin typeface="Segoe UI"/>
               </a:rPr>
               <a:t>Prints Python 3.14.x  →  all three installs are correct</a:t>
-            </a:r>
-          </a:p>
-          <a:p>
-            <a:pPr>
-              <a:spcBef>
-                <a:spcPts val="0"/>
-              </a:spcBef>
-              <a:spcAft>
-                <a:spcPts val="1000"/>
-              </a:spcAft>
-            </a:pPr>
-            <a:r>
-              <a:rPr sz="1900" b="1" i="0">
-                <a:solidFill>
-                  <a:srgbClr val="0EA5E9"/>
-                </a:solidFill>
-                <a:latin typeface="Segoe UI"/>
-              </a:rPr>
-              <a:t>▪  </a:t>
-            </a:r>
-            <a:r>
-              <a:rPr sz="1900" b="0" i="0">
-                <a:solidFill>
-                  <a:srgbClr val="334155"/>
-                </a:solidFill>
-                <a:latin typeface="Segoe UI"/>
-              </a:rPr>
-              <a:t>Teacher tip: have everyone read out their python --version</a:t>
             </a:r>
           </a:p>
         </p:txBody>
@@ -9604,37 +9878,105 @@
           <a:bodyPr wrap="square" lIns="182880" tIns="109728" rtlCol="0" anchor="t"/>
           <a:lstStyle/>
           <a:p>
-            <a:pPr algn="ctr"/>
-            <a:r>
-              <a:rPr sz="1400" b="0" i="0">
+            <a:r>
+              <a:rPr sz="1400" b="0" i="0" dirty="0">
                 <a:solidFill>
                   <a:srgbClr val="0F172A"/>
                 </a:solidFill>
                 <a:latin typeface="Consolas"/>
               </a:rPr>
-              <a:t>python -m venv .venv</a:t>
-            </a:r>
-          </a:p>
-          <a:p>
-            <a:r>
-              <a:rPr sz="1400" b="0" i="0">
+              <a:t>python -m </a:t>
+            </a:r>
+            <a:r>
+              <a:rPr sz="1400" b="0" i="0" dirty="0" err="1">
                 <a:solidFill>
                   <a:srgbClr val="0F172A"/>
                 </a:solidFill>
                 <a:latin typeface="Consolas"/>
               </a:rPr>
-              <a:t>.venv\Scripts\Activate.ps1     # Windows (PowerShell)</a:t>
-            </a:r>
-          </a:p>
-          <a:p>
-            <a:r>
-              <a:rPr sz="1400" b="0" i="0">
+              <a:t>venv</a:t>
+            </a:r>
+            <a:r>
+              <a:rPr sz="1400" b="0" i="0" dirty="0">
                 <a:solidFill>
                   <a:srgbClr val="0F172A"/>
                 </a:solidFill>
                 <a:latin typeface="Consolas"/>
               </a:rPr>
-              <a:t>source .venv/bin/activate      # macOS / Linux</a:t>
+              <a:t> .</a:t>
+            </a:r>
+            <a:r>
+              <a:rPr sz="1400" b="0" i="0" dirty="0" err="1">
+                <a:solidFill>
+                  <a:srgbClr val="0F172A"/>
+                </a:solidFill>
+                <a:latin typeface="Consolas"/>
+              </a:rPr>
+              <a:t>venv</a:t>
+            </a:r>
+            <a:endParaRPr sz="1400" b="0" i="0" dirty="0">
+              <a:solidFill>
+                <a:srgbClr val="0F172A"/>
+              </a:solidFill>
+              <a:latin typeface="Consolas"/>
+            </a:endParaRPr>
+          </a:p>
+          <a:p>
+            <a:r>
+              <a:rPr sz="1400" b="0" i="0" dirty="0">
+                <a:solidFill>
+                  <a:srgbClr val="0F172A"/>
+                </a:solidFill>
+                <a:latin typeface="Consolas"/>
+              </a:rPr>
+              <a:t>.</a:t>
+            </a:r>
+            <a:r>
+              <a:rPr sz="1400" b="0" i="0" dirty="0" err="1">
+                <a:solidFill>
+                  <a:srgbClr val="0F172A"/>
+                </a:solidFill>
+                <a:latin typeface="Consolas"/>
+              </a:rPr>
+              <a:t>venv</a:t>
+            </a:r>
+            <a:r>
+              <a:rPr sz="1400" b="0" i="0" dirty="0">
+                <a:solidFill>
+                  <a:srgbClr val="0F172A"/>
+                </a:solidFill>
+                <a:latin typeface="Consolas"/>
+              </a:rPr>
+              <a:t>\Scripts\Activate.ps1     # Windows (PowerShell)</a:t>
+            </a:r>
+          </a:p>
+          <a:p>
+            <a:r>
+              <a:rPr sz="1400" b="0" i="0" dirty="0">
+                <a:solidFill>
+                  <a:srgbClr val="0F172A"/>
+                </a:solidFill>
+                <a:latin typeface="Consolas"/>
+              </a:rPr>
+              <a:t>source .</a:t>
+            </a:r>
+            <a:r>
+              <a:rPr sz="1400" b="0" i="0" dirty="0" err="1">
+                <a:solidFill>
+                  <a:srgbClr val="0F172A"/>
+                </a:solidFill>
+                <a:latin typeface="Consolas"/>
+              </a:rPr>
+              <a:t>venv</a:t>
+            </a:r>
+            <a:r>
+              <a:rPr sz="1400" b="0" i="0" dirty="0">
+                <a:solidFill>
+                  <a:srgbClr val="0F172A"/>
+                </a:solidFill>
+                <a:latin typeface="Consolas"/>
+              </a:rPr>
+              <a:t>/bin/activate      # macOS / Linux</a:t>
             </a:r>
           </a:p>
         </p:txBody>

</xml_diff>